<commit_message>
Fix: PPTX slideMaster+slideLayout+theme qo'shildi — PowerPoint endi ochadi
</commit_message>
<xml_diff>
--- a/Metrologik_Noaniqlik_Qaror.pptx
+++ b/Metrologik_Noaniqlik_Qaror.pptx
@@ -1,7 +1,9 @@
 
 <file path=ppt/presentation.xml><?xml version="1.0" encoding="utf-8"?>
 <p:presentation xmlns:a="http://schemas.openxmlformats.org/drawingml/2006/main" xmlns:p="http://schemas.openxmlformats.org/presentationml/2006/main" xmlns:r="http://schemas.openxmlformats.org/officeDocument/2006/relationships" saveSubsetFonts="1">
-  <p:sldMasterIdLst/>
+  <p:sldMasterIdLst>
+    <p:sldMasterId id="2147483648" r:id="rIdM1"/>
+  </p:sldMasterIdLst>
   <p:sldSz cx="9144000" cy="5143500" type="custom"/>
   <p:notesSz cx="6858000" cy="9144000"/>
   <p:sldIdLst>
@@ -17,6 +19,81 @@
     <p:sldId id="265" r:id="rId10"/>
   </p:sldIdLst>
 </p:presentation>
+</file>
+
+<file path=ppt/slideLayouts/slideLayout1.xml><?xml version="1.0" encoding="utf-8"?>
+<p:sldLayout xmlns:a="http://schemas.openxmlformats.org/drawingml/2006/main" xmlns:r="http://schemas.openxmlformats.org/officeDocument/2006/relationships" xmlns:p="http://schemas.openxmlformats.org/presentationml/2006/main" type="blank" preserve="1">
+  <p:cSld name="Blank">
+    <p:spTree>
+      <p:nvGrpSpPr>
+        <p:cNvPr id="1" name=""/>
+        <p:cNvGrpSpPr/>
+        <p:nvPr/>
+      </p:nvGrpSpPr>
+      <p:grpSpPr>
+        <a:xfrm>
+          <a:off x="0" y="0"/>
+          <a:ext cx="0" cy="0"/>
+          <a:chOff x="0" y="0"/>
+          <a:chExt cx="0" cy="0"/>
+        </a:xfrm>
+      </p:grpSpPr>
+    </p:spTree>
+  </p:cSld>
+  <p:clrMapOvr>
+    <a:masterClrMapping/>
+  </p:clrMapOvr>
+</p:sldLayout>
+</file>
+
+<file path=ppt/slideMasters/slideMaster1.xml><?xml version="1.0" encoding="UTF-8" standalone="yes"?>
+<p:sldMaster xmlns:a="http://schemas.openxmlformats.org/drawingml/2006/main"
+  xmlns:r="http://schemas.openxmlformats.org/officeDocument/2006/relationships"
+  xmlns:p="http://schemas.openxmlformats.org/presentationml/2006/main">
+  <p:cSld><p:bg><p:bgRef idx="1001">
+    <a:schemeClr val="bg1"/>
+  </p:bgRef></p:bg>
+  <p:spTree>
+    <p:nvGrpSpPr>
+      <p:cNvPr id="1" name=""/>
+      <p:cNvGrpSpPr/>
+      <p:nvPr/>
+    </p:nvGrpSpPr>
+    <p:grpSpPr>
+      <a:xfrm><a:off x="0" y="0"/>
+      <a:ext cx="0" cy="0"/>
+      <a:chOff x="0" y="0"/>
+      <a:chExt cx="0" cy="0"/></a:xfrm>
+    </p:grpSpPr>
+  </p:spTree>
+  </p:cSld>
+  <p:clrMap bg1="lt1" tx1="dk1" bg2="lt2" tx2="dk2"
+    accent1="accent1" accent2="accent2" accent3="accent3"
+    accent4="accent4" accent5="accent5" accent6="accent6"
+    hlink="hlink" folHlink="folHlink"/>
+  <p:sldLayoutIdLst>
+    <p:sldLayoutId id="2147483649" r:id="rId1"/>
+  </p:sldLayoutIdLst>
+  <p:txStyles>
+    <p:titleStyle>
+      <a:lvl1pPr><a:defRPr lang="uz-UZ" sz=2800 b="1">
+        <a:solidFill><a:srgbClr val="FFFFFF"/></a:solidFill>
+        <a:latin typeface="Calibri"/>
+      </a:defRPr></a:lvl1pPr>
+    </p:titleStyle>
+    <p:bodyStyle>
+      <a:lvl1pPr><a:defRPr lang="uz-UZ" sz=1800>
+        <a:solidFill><a:srgbClr val="000000"/></a:solidFill>
+        <a:latin typeface="Calibri"/>
+      </a:defRPr></a:lvl1pPr>
+    </p:bodyStyle>
+    <p:otherStyle>
+      <a:defPPr><a:defRPr lang="uz-UZ">
+        <a:latin typeface="Calibri"/>
+      </a:defRPr></a:defPPr>
+    </p:otherStyle>
+  </p:txStyles>
+</p:sldMaster>
 </file>
 
 <file path=ppt/slides/slide1.xml><?xml version="1.0" encoding="utf-8"?>
@@ -15532,4 +15609,113 @@
     </p:spTree>
   </p:cSld>
 </p:sld>
+</file>
+
+<file path=ppt/theme/theme1.xml><?xml version="1.0" encoding="utf-8"?>
+<a:theme xmlns:a="http://schemas.openxmlformats.org/drawingml/2006/main" name="Office Theme">
+  <a:themeElements>
+    <a:clrScheme name="Office">
+      <a:dk1>
+        <a:sysClr val="windowText" lastClr="000000"/>
+      </a:dk1>
+      <a:lt1>
+        <a:sysClr val="window" lastClr="FFFFFF"/>
+      </a:lt1>
+      <a:dk2>
+        <a:srgbClr val="44546A"/>
+      </a:dk2>
+      <a:lt2>
+        <a:srgbClr val="E7E6E6"/>
+      </a:lt2>
+      <a:accent1>
+        <a:srgbClr val="4472C4"/>
+      </a:accent1>
+      <a:accent2>
+        <a:srgbClr val="ED7D31"/>
+      </a:accent2>
+      <a:accent3>
+        <a:srgbClr val="A9D18E"/>
+      </a:accent3>
+      <a:accent4>
+        <a:srgbClr val="FFC000"/>
+      </a:accent4>
+      <a:accent5>
+        <a:srgbClr val="5A96C5"/>
+      </a:accent5>
+      <a:accent6>
+        <a:srgbClr val="70AD47"/>
+      </a:accent6>
+      <a:hlink>
+        <a:srgbClr val="0563C1"/>
+      </a:hlink>
+      <a:folHlink>
+        <a:srgbClr val="954F72"/>
+      </a:folHlink>
+    </a:clrScheme>
+    <a:fontScheme name="Office">
+      <a:majorFont>
+        <a:latin typeface="Calibri Light"/>
+        <a:ea typeface=""/>
+        <a:cs typeface=""/>
+      </a:majorFont>
+      <a:minorFont>
+        <a:latin typeface="Calibri"/>
+        <a:ea typeface=""/>
+        <a:cs typeface=""/>
+      </a:minorFont>
+    </a:fontScheme>
+    <a:fmtScheme name="Office">
+      <a:fillStyleLst>
+        <a:solidFill>
+          <a:schemeClr val="phClr"/>
+        </a:solidFill>
+        <a:solidFill>
+          <a:schemeClr val="phClr"/>
+        </a:solidFill>
+        <a:solidFill>
+          <a:schemeClr val="phClr"/>
+        </a:solidFill>
+      </a:fillStyleLst>
+      <a:lnStyleLst>
+        <a:ln w="6350">
+          <a:solidFill>
+            <a:schemeClr val="phClr"/>
+          </a:solidFill>
+        </a:ln>
+        <a:ln w="12700">
+          <a:solidFill>
+            <a:schemeClr val="phClr"/>
+          </a:solidFill>
+        </a:ln>
+        <a:ln w="19050">
+          <a:solidFill>
+            <a:schemeClr val="phClr"/>
+          </a:solidFill>
+        </a:ln>
+      </a:lnStyleLst>
+      <a:effectStyleLst>
+        <a:effectStyle>
+          <a:effectLst/>
+        </a:effectStyle>
+        <a:effectStyle>
+          <a:effectLst/>
+        </a:effectStyle>
+        <a:effectStyle>
+          <a:effectLst/>
+        </a:effectStyle>
+      </a:effectStyleLst>
+      <a:bgFillStyleLst>
+        <a:solidFill>
+          <a:schemeClr val="phClr"/>
+        </a:solidFill>
+        <a:solidFill>
+          <a:schemeClr val="phClr"/>
+        </a:solidFill>
+        <a:solidFill>
+          <a:schemeClr val="phClr"/>
+        </a:solidFill>
+      </a:bgFillStyleLst>
+    </a:fmtScheme>
+  </a:themeElements>
+</a:theme>
 </file>
</xml_diff>